<commit_message>
Apply second-round source verification to report and deck
Use Pew's exact figures (28% all teens, 24% ages 13-14, 44% among
chatbot users); retract the Data Hub 6.7% vs 20% claim (QoQ vs YoY);
add USC classifier-validation accuracy; describe PwC as global without
the unconfirmed territory count; note the U.S. 50% cancel figure is
only found as a six-country 49%; mark Fabric/Antenna figures as relayed.

Co-Authored-By: Claude Opus 5.5 <noreply@anthropic.com>
Claude-Session: https://claude.ai/code/session_01GVqMkWurYUK1ig7fiBE8me
</commit_message>
<xml_diff>
--- a/Gracenote_AI报告解读_课堂分享.pptx
+++ b/Gracenote_AI报告解读_课堂分享.pptx
@@ -122,26 +122,26 @@
   <p:extLst>
     <p:ext uri="{521415D9-36F7-43E2-AB2F-B90AF26B5E84}">
       <p14:sectionLst xmlns:p14="http://schemas.microsoft.com/office/powerpoint/2010/main">
-        <p14:section name="开场" id="{cd12cae7-5102-3bb7-482f-4309740b5675}">
+        <p14:section name="开场" id="{4e41b6b1-80dc-8730-53af-78eb833089e9}">
           <p14:sldIdLst>
             <p14:sldId id="256"/>
           </p14:sldIdLst>
         </p14:section>
-        <p14:section name="报告介绍" id="{289f321f-4ee6-2466-5e93-1031312149fb}">
+        <p14:section name="报告介绍" id="{3d69bc0e-6c67-eb1e-1a6e-0b8d83064a2c}">
           <p14:sldIdLst>
             <p14:sldId id="257"/>
             <p14:sldId id="258"/>
             <p14:sldId id="259"/>
           </p14:sldIdLst>
         </p14:section>
-        <p14:section name="主要发现" id="{e1ee1420-fa8e-147d-07fe-c57b749c3598}">
+        <p14:section name="主要发现" id="{da7c2405-af86-4d89-8ef6-f0540895ead3}">
           <p14:sldIdLst>
             <p14:sldId id="260"/>
             <p14:sldId id="261"/>
             <p14:sldId id="262"/>
           </p14:sldIdLst>
         </p14:section>
-        <p14:section name="评价与局限" id="{32276f2d-0992-0981-6df9-60b7e8b8540b}">
+        <p14:section name="评价与局限" id="{970e456e-877c-2760-a88e-b78488070c1b}">
           <p14:sldIdLst>
             <p14:sldId id="263"/>
             <p14:sldId id="264"/>
@@ -153,7 +153,7 @@
             <p14:sldId id="270"/>
           </p14:sldIdLst>
         </p14:section>
-        <p14:section name="结论" id="{e110f31f-b168-1742-d087-6b445fb9abb5}">
+        <p14:section name="结论" id="{9d21c3e5-ab1a-e1bc-554d-018118fbf98f}">
           <p14:sldIdLst>
             <p14:sldId id="271"/>
           </p14:sldIdLst>
@@ -1836,7 +1836,7 @@
           <a:p>
             <a:r>
               <a:rPr lang="en-US" dirty="0"/>
-              <a:t>第三个局限是我对照 Gracenote 上一份报告原文发现的。2026 报告里的'平均找节目 14 分钟'，其实是巴西、法国、德国、墨西哥、英国、美国六国的简单平均，美国自己是 12 分钟，法国一国 26 分钟把平均拉高了。但报告把 14 分钟和美国尼尔森的收视数据画在了同一张图里。摘要里'18 到 34 岁 54% 会取消订阅'也和六国数据吻合。还有第 9 页 32% 和第 12 页 34% 对不上，原因很可能就是一个是六国平均、一个是美国。也就是说，读者很容易把六国数字当成美国数字。</a:t>
+              <a:t>第三个局限是我对照 Gracenote 上一份报告原文发现的。2026 报告里的'平均找节目 14 分钟'，其实是巴西、法国、德国、墨西哥、英国、美国六国的简单平均，美国自己是 12 分钟，法国一国 26 分钟把平均拉高了。但报告把 14 分钟和美国尼尔森的收视数据画在了同一张图里。摘要里'18 到 34 岁 54% 会取消订阅'也和六国数据吻合；报告说'50% 的美国观众会考虑取消'，原始材料里只找得到六国的 49%。还有第 9 页 32% 和第 12 页 34%，两页措辞略有不同，但对应同一道题，32% 和六国平均一致，34% 写的是美国人。也就是说，读者很容易把六国数字当成美国数字。</a:t>
             </a:r>
             <a:endParaRPr lang="en-US" dirty="0"/>
           </a:p>
@@ -1924,7 +1924,7 @@
           <a:p>
             <a:r>
               <a:rPr lang="en-US" dirty="0"/>
-              <a:t>第三个局限最像春晚案例。报告拿 Pew 的 30% 和自己的 54% 对比，说几个月内使用频率在加速。但我们用春晚的四个角度对一下：对象不同，Pew 是所有 13 到 17 岁青少年，Gracenote 是 13 到 14 岁的 AI 用户；方法不同，Pew 是基于随机地址抽样的样本库并加权；时间也不同。关键是分母：Pew 原文是 64% 的青少年用过聊天机器人，约 3 成每天用，这 3 成是对所有青少年算的。换成和 Gracenote 一样的'使用者'分母，大约是 47%，和 54% 只差 7 个百分点左右。所以表面上 24 个百分点的差距，大部分来自分母不同，不能解释成增长。</a:t>
+              <a:t>第三个局限最像春晚案例。报告拿 Pew 的 30% 和自己的 54% 对比，说几个月内使用频率在加速。但我们用春晚的四个角度对一下：对象不同，Pew 是所有 13 到 17 岁青少年，Gracenote 是 13 到 14 岁的 AI 用户；方法不同，Pew 是基于随机地址抽样的样本库并加权；时间也不同。关键是分母。Pew 的数据表里，所有青少年每天用的精确值是 28%，其中 13 到 14 岁只有 24%；而 Gracenote 同样是 13 到 14 岁，却是 54%。区别在于 Pew 问的是所有青少年，Gracenote 只问 AI 用户。换成同样的'使用者'分母，Pew 是 44%，和 54% 只差 10 个百分点左右，剩下的还可能来自年龄、方法和时间不同。所以这个差距不能解释成增长。</a:t>
             </a:r>
             <a:endParaRPr lang="en-US" dirty="0"/>
           </a:p>
@@ -2012,7 +2012,7 @@
           <a:p>
             <a:r>
               <a:rPr lang="en-US" dirty="0"/>
-              <a:t>第五个局限是指标类型。报告用了四种完全不同的数据：问卷里说'可能会退订'是意向，而且是六国口径；5.5% 的月流失率是实际行为，但另一家机构 Antenna 测得 2019 年就已经是 4.1%，和报告说的 2% 差了一倍，说明定义不同；3185 亿美元是 PwC 对全球 54 个市场的预测，不是美国；三分之二找对平台是多国合并的测试结果，ChatGPT 在美英德约八成正确，在法意西不到三成。报告把它们串成'找不到节目导致退订，所以需要 AI 和可信数据'。但它没有追踪同一批人，也没有做实验，所以这条因果链没有被证明。</a:t>
+              <a:t>第五个局限是指标类型。报告用了四种完全不同的数据：问卷里说'可能会退订'是意向，而且是六国口径；5.5% 的月流失率是实际行为，但另一家机构 Antenna 测得 2019 年就已经是 4.1%，和报告说的 2% 差了一倍，说明定义不同；3185 亿美元是 PwC 对全球市场的预测，不是美国；三分之二找对平台是六个国家合并的测试结果，而且只测独播剧，ChatGPT 在美英德约八成正确，在法意西不到三成。报告把它们串成'找不到节目导致退订，所以需要 AI 和可信数据'。但它没有追踪同一批人，也没有做实验，所以这条因果链没有被证明。</a:t>
             </a:r>
             <a:endParaRPr lang="en-US" dirty="0"/>
           </a:p>
@@ -2100,7 +2100,7 @@
           <a:p>
             <a:r>
               <a:rPr lang="en-US" dirty="0"/>
-              <a:t>第六个局限是几处引用和口径。比如 USC 那个 38%，原论文里只是一个知识库在一个指标下的数，另一个库只有 3% 到 4%；Deloitte 的 41% 原文是所有消费者，报告写成了订户；摘要说'会取消'，正文是'会考虑取消'。PwC 的 3185 亿美元其实是全球 54 个市场的合计；核查图里 83% 大于 58%，分母没写清。这些不一定推翻大方向，但提醒我们引用二手数据要回原文核对。</a:t>
+              <a:t>第六个局限是几处引用和口径。比如 USC 那个 38%，原论文里只是一个知识库在一个指标下的数，而且是自动分类器判的，这个指标和人工判断的一致率只有六成，另一个库只有 3% 到 4%；Deloitte 的 41% 原文是所有消费者，报告写成了订户；摘要说'会取消'，正文是'会考虑取消'。PwC 的 3185 亿美元其实是全球数字；核查图里 83% 大于 58%，分母没写清。这些不一定推翻大方向，但提醒我们引用二手数据要回原文核对。</a:t>
             </a:r>
             <a:endParaRPr lang="en-US" dirty="0"/>
           </a:p>
@@ -5243,7 +5243,7 @@
                   <a:schemeClr val="accent3"/>
                 </a:solidFill>
               </a:rPr>
-              <a:t>54%</a:t>
+              <a:t>54% 与 50%</a:t>
             </a:r>
             <a:endParaRPr lang="en-US" sz="2000" dirty="0"/>
           </a:p>
@@ -5279,7 +5279,7 @@
                   <a:schemeClr val="tx1"/>
                 </a:solidFill>
               </a:rPr>
-              <a:t>摘要里“18–34 岁会取消订阅”的比例，与六国数据吻合（18–24 岁 52%、25–34 岁 56%），却和美国数据并列。</a:t>
+              <a:t>摘要“18–34 岁 54% 会取消”与六国数据吻合（18–24 岁 52%、25–34 岁 56%）；“50% 的美国观众会考虑取消”原文只找到六国 49%。</a:t>
             </a:r>
             <a:endParaRPr lang="en-US" sz="1300" dirty="0"/>
           </a:p>
@@ -5378,7 +5378,7 @@
                   <a:schemeClr val="tx1"/>
                 </a:solidFill>
               </a:rPr>
-              <a:t>第 9 页的 32% 是六国平均；第 12 页的 34% 写的是“美国人”。两页数字不同，原因很可能就是口径不同。</a:t>
+              <a:t>两页措辞略异，但对应同一道题。32% 与六国平均一致；第 12 页写成“34% 的美国人”。两页的“18–34 岁 48%”都高于六国同龄的 39%–40%。</a:t>
             </a:r>
             <a:endParaRPr lang="en-US" sz="1300" dirty="0"/>
           </a:p>
@@ -6494,7 +6494,7 @@
                             <a:schemeClr val="tx1"/>
                           </a:solidFill>
                         </a:rPr>
-                        <a:t>64% 用过聊天机器人；约 30% 每天用</a:t>
+                        <a:t>64% 用过；每天用 28%，其中 13–14 岁 24%</a:t>
                       </a:r>
                       <a:endParaRPr lang="en-US" sz="1400" dirty="0"/>
                     </a:p>
@@ -6555,7 +6555,7 @@
                             <a:schemeClr val="tx1"/>
                           </a:solidFill>
                         </a:rPr>
-                        <a:t>54% 每天使用</a:t>
+                        <a:t>13–14 岁：54% 每天使用</a:t>
                       </a:r>
                       <a:endParaRPr lang="en-US" sz="1400" dirty="0"/>
                     </a:p>
@@ -6679,7 +6679,7 @@
                             <a:schemeClr val="accent3"/>
                           </a:solidFill>
                         </a:rPr>
-                        <a:t>使用者中每天用：30% ÷ 64% ≈ 47%</a:t>
+                        <a:t>使用者中每天用：44%（894 人）</a:t>
                       </a:r>
                       <a:endParaRPr lang="en-US" sz="1400" dirty="0"/>
                     </a:p>
@@ -6849,7 +6849,7 @@
                   <a:schemeClr val="accent3"/>
                 </a:solidFill>
               </a:rPr>
-              <a:t>换成同一分母，差距从 24 个百分点缩到约 7 个；剩下的差距还可能来自年龄、方法、时间不同，不能说明“加速”。</a:t>
+              <a:t>同为 13–14 岁：24% 对 54%，差距主要来自分母。换成使用者分母只差约 10 个百分点，不能说明“加速”。</a:t>
             </a:r>
             <a:endParaRPr lang="en-US" sz="1500" dirty="0"/>
           </a:p>
@@ -7488,7 +7488,7 @@
                   <a:schemeClr val="accent5"/>
                 </a:solidFill>
               </a:rPr>
-              <a:t>Fabric，定义未公开</a:t>
+              <a:t>Fabric 原页未见此数，定义未公开</a:t>
             </a:r>
             <a:endParaRPr lang="en-US" sz="1400" dirty="0"/>
           </a:p>
@@ -7675,7 +7675,7 @@
                   <a:schemeClr val="tx1"/>
                 </a:solidFill>
               </a:rPr>
-              <a:t>OTT 与付费电视 2029 年支出，是全球 54 个市场合计</a:t>
+              <a:t>OTT 与付费电视 2029 年支出，是全球数字，不是美国</a:t>
             </a:r>
             <a:endParaRPr lang="en-US" sz="1400" dirty="0"/>
           </a:p>
@@ -7896,7 +7896,7 @@
                   <a:schemeClr val="accent5"/>
                 </a:solidFill>
               </a:rPr>
-              <a:t>Veed，多国合并值</a:t>
+              <a:t>Veed，6 国合并、只测独播剧</a:t>
             </a:r>
             <a:endParaRPr lang="en-US" sz="1400" dirty="0"/>
           </a:p>
@@ -8308,7 +8308,7 @@
                   </a:tcPr>
                 </a:tc>
               </a:tr>
-              <a:tr h="713232">
+              <a:tr h="868680">
                 <a:tc>
                   <a:txBody>
                     <a:bodyPr/>
@@ -8384,7 +8384,7 @@
                             <a:schemeClr val="tx1"/>
                           </a:solidFill>
                         </a:rPr>
-                        <a:t>38.6% 只是 GenericsKB 一个知识库在 regard 指标下的比例；另一个库 ConceptNet 是 3.4%–4.5%</a:t>
+                        <a:t>38.6% 只是 GenericsKB 一个库在 regard 指标下的比例，由自动分类器判定，该指标与人工判断的一致率仅 60.9%；另一个库 ConceptNet 是 3.4%–4.5%</a:t>
                       </a:r>
                       <a:endParaRPr lang="en-US" sz="1300" dirty="0"/>
                     </a:p>
@@ -8432,7 +8432,7 @@
                   </a:tcPr>
                 </a:tc>
               </a:tr>
-              <a:tr h="713232">
+              <a:tr h="658368">
                 <a:tc>
                   <a:txBody>
                     <a:bodyPr/>
@@ -8556,7 +8556,7 @@
                   </a:tcPr>
                 </a:tc>
               </a:tr>
-              <a:tr h="548640">
+              <a:tr h="502920">
                 <a:tc>
                   <a:txBody>
                     <a:bodyPr/>
@@ -8680,7 +8680,7 @@
                   </a:tcPr>
                 </a:tc>
               </a:tr>
-              <a:tr h="713232">
+              <a:tr h="658368">
                 <a:tc>
                   <a:txBody>
                     <a:bodyPr/>
@@ -8756,7 +8756,7 @@
                             <a:schemeClr val="tx1"/>
                           </a:solidFill>
                         </a:rPr>
-                        <a:t>这是全球 54 个国家和地区的合计（2024 年 2,913 亿，年增 1.8%），报告没写明是全球</a:t>
+                        <a:t>这是全球数字（2024 年 2,913 亿，年增 1.8%），报告没写明是全球</a:t>
                       </a:r>
                       <a:endParaRPr lang="en-US" sz="1300" dirty="0"/>
                     </a:p>
@@ -8804,7 +8804,7 @@
                   </a:tcPr>
                 </a:tc>
               </a:tr>
-              <a:tr h="713232">
+              <a:tr h="658368">
                 <a:tc>
                   <a:txBody>
                     <a:bodyPr/>
@@ -14703,7 +14703,7 @@
                   <a:schemeClr val="tx1"/>
                 </a:solidFill>
               </a:rPr>
-              <a:t>公开数据 + 行业访谈 + 建模；54 个国家和地区合计</a:t>
+              <a:t>公开数据 + 行业访谈 + 建模；全球市场合计</a:t>
             </a:r>
             <a:endParaRPr lang="en-US" sz="1400" dirty="0"/>
           </a:p>
@@ -14858,7 +14858,7 @@
                   <a:schemeClr val="tx1"/>
                 </a:solidFill>
               </a:rPr>
-              <a:t>美欧多国提问评分；题量、日期、评分标准未公开</a:t>
+              <a:t>6 国、只测独播剧、每题问 3 次；题量、模型版本、评分程序未公开</a:t>
             </a:r>
             <a:endParaRPr lang="en-US" sz="1400" dirty="0"/>
           </a:p>
@@ -15013,7 +15013,7 @@
                   <a:schemeClr val="tx1"/>
                 </a:solidFill>
               </a:rPr>
-              <a:t>同行评审论文（EMNLP 2021），两个知识库、自动指标</a:t>
+              <a:t>同行评审论文；自动分类器判定 + 众包抽样人工验证</a:t>
             </a:r>
             <a:endParaRPr lang="en-US" sz="1400" dirty="0"/>
           </a:p>
@@ -15168,7 +15168,7 @@
                   <a:schemeClr val="tx1"/>
                 </a:solidFill>
               </a:rPr>
-              <a:t>自动抓取 + 人工核验；流失率定义未公开</a:t>
+              <a:t>Fabric 原页未见 5.5% 与 2%；流失率定义未公开</a:t>
             </a:r>
             <a:endParaRPr lang="en-US" sz="1400" dirty="0"/>
           </a:p>

</xml_diff>

<commit_message>
Drop slide footer; rewrite for an audience new to the report
Remove the running footer (slide numbers stay). Introduce each
organisation and term on first mention, drop page-number references
and jargon such as MCP and CTV, add a background line, and name the two
surveys consistently. Script rebalanced to about 4:40.

Co-Authored-By: Claude Opus 5.5 <noreply@anthropic.com>
Claude-Session: https://claude.ai/code/session_01GVqMkWurYUK1ig7fiBE8me
</commit_message>
<xml_diff>
--- a/Gracenote_AI报告解读_课堂分享.pptx
+++ b/Gracenote_AI报告解读_课堂分享.pptx
@@ -118,19 +118,19 @@
   <p:extLst>
     <p:ext uri="{521415D9-36F7-43E2-AB2F-B90AF26B5E84}">
       <p14:sectionLst xmlns:p14="http://schemas.microsoft.com/office/powerpoint/2010/main">
-        <p14:section name="开场" id="{a496ad52-5f88-b379-3fbd-3ede41a5f0ab}">
+        <p14:section name="开场" id="{d53c7028-9b7d-c3b4-aa4d-2211863fc93a}">
           <p14:sldIdLst>
             <p14:sldId id="256"/>
           </p14:sldIdLst>
         </p14:section>
-        <p14:section name="报告介绍" id="{cde322d0-870f-b201-cc10-efa4386d4bfa}">
+        <p14:section name="报告介绍" id="{f4a8d30b-7ca5-4a81-bf48-ac0b9bddc29e}">
           <p14:sldIdLst>
             <p14:sldId id="257"/>
             <p14:sldId id="258"/>
             <p14:sldId id="259"/>
           </p14:sldIdLst>
         </p14:section>
-        <p14:section name="评价" id="{109cbb1c-6d3a-2606-bdac-0f9028e75eda}">
+        <p14:section name="评价" id="{902a1cad-474a-9536-82d3-89597934c865}">
           <p14:sldIdLst>
             <p14:sldId id="260"/>
             <p14:sldId id="261"/>
@@ -139,12 +139,12 @@
             <p14:sldId id="264"/>
           </p14:sldIdLst>
         </p14:section>
-        <p14:section name="结论" id="{490a992c-4118-0559-cf32-78c1a7dd656e}">
+        <p14:section name="结论" id="{be88bb5e-ca8f-6292-4e1f-3c31841d4ef8}">
           <p14:sldIdLst>
             <p14:sldId id="265"/>
           </p14:sldIdLst>
         </p14:section>
-        <p14:section name="附录（备问）" id="{2110f5b5-abd4-6d65-0387-67286c4f41a7}">
+        <p14:section name="附录（备问）" id="{a2fb4f44-b982-4fe6-c725-b96e5a8c16d2}">
           <p14:sldIdLst>
             <p14:sldId id="266"/>
             <p14:sldId id="267"/>
@@ -185,7 +185,7 @@
                 </a:solidFill>
                 <a:latin typeface="+mn-lt"/>
               </a:rPr>
-              <a:t>找到想看的节目要几分钟（2025 调查原文）</a:t>
+              <a:t>找到想看的节目要几分钟（六国调查的原始报告）</a:t>
             </a:r>
           </a:p>
         </c:rich>
@@ -913,7 +913,7 @@
           <a:p>
             <a:r>
               <a:rPr lang="en-US" dirty="0"/>
-              <a:t>【约 20 秒】大家好。我分享的是尼尔森旗下 Gracenote 今年 4 月的报告。它有个很抓眼的数字：54% 的 13 到 14 岁孩子每天都用 AI。我想追问的是：这个数字代表的是谁？</a:t>
+              <a:t>【约 25 秒】大家好。我分享的是尼尔森旗下 Gracenote 今年 4 月发布的一份行业报告，讲的是 AI 怎样改变人们找电视节目。里面有个很抓眼的数字：54% 的 13 到 14 岁孩子每天都用 AI。我想追问：这个数字代表的是谁？</a:t>
             </a:r>
             <a:endParaRPr lang="en-US" dirty="0"/>
           </a:p>
@@ -1001,7 +1001,7 @@
           <a:p>
             <a:r>
               <a:rPr lang="en-US" dirty="0"/>
-              <a:t>【约 25 秒】我的评价是：报告公开了样本量、时间和年龄，图里的数字我复算也对得上，可以当作行业方向的信号；但不宜当作对“美国人”的精确估计，更不是因果证据。留个问题给大家：要验证“找不到节目会导致退订”，你会怎么设计调查？谢谢大家。</a:t>
+              <a:t>【约 25 秒】我的评价是：报告公开了样本量、时间和年龄，图里的数字我复算也对得上，可以当作行业趋势的信号；但不能当作“美国人”的精确数据，也不是因果证据。最后留个问题：要验证“找不到节目会导致退订”，你会怎么设计调查？谢谢大家。</a:t>
             </a:r>
             <a:endParaRPr lang="en-US" dirty="0"/>
           </a:p>
@@ -1265,7 +1265,7 @@
           <a:p>
             <a:r>
               <a:rPr lang="en-US" dirty="0"/>
-              <a:t>【约 25 秒】报告问了三个问题：大家怎么用 AI 找信息；平台这么多，找节目有多难、会不会因此退订；观众信不信 AI 的答案。做报告的 Gracenote 本身就卖节目数据，它的主张是：AI 会成为找节目的入口，但必须接入可信的行业数据。</a:t>
+              <a:t>【约 35 秒】先说背景：平台越来越多，想看一部剧常常不知道去哪找，很多人干脆直接问 ChatGPT。报告就问了三件事：怎么用 AI 找信息；找节目有多难、会不会因此退订；信不信 AI 的答案。做报告的 Gracenote 专门给平台提供节目资料，它主张 AI 必须接入可信的行业数据，也就是它卖的东西。</a:t>
             </a:r>
             <a:endParaRPr lang="en-US" dirty="0"/>
           </a:p>
@@ -1353,7 +1353,7 @@
           <a:p>
             <a:r>
               <a:rPr lang="en-US" dirty="0"/>
-              <a:t>【约 30 秒】按老师要求的对象、时间、抽样、样本量来看。核心是两份线上问卷：一份是今年 1 到 2 月，4003 名美国 AI 聊天机器人用户；另一份是去年夏天，六个国家各 500 名流媒体用户。最关键的是橙色这一行：两份都没公开样本从哪里招、怎么加权、回应率多少。</a:t>
+              <a:t>【约 25 秒】按老师要求的四项看方法。报告主要靠两份线上问卷：一份是今年 1 到 2 月，4003 名美国 AI 聊天机器人用户；另一份是去年夏天，六个国家各 500 名流媒体用户。关键在橙色这一行：两份都没公开样本从哪里招、怎么加权、回应率多少。</a:t>
             </a:r>
             <a:endParaRPr lang="en-US" dirty="0"/>
           </a:p>
@@ -1441,7 +1441,7 @@
           <a:p>
             <a:r>
               <a:rPr lang="en-US" dirty="0"/>
-              <a:t>【约 30 秒】结论有四个数字：13 到 14 岁的 AI 用户 54% 每天用；75% 会核查 AI 的答案；平均找一个节目要 14 分钟；18 到 34 岁有 54% 说找不到想看的可能会退订。报告由此推出：大家依赖 AI 又不信任 AI，节目难找导致退订，所以 AI 要接入可信数据。</a:t>
+              <a:t>【约 30 秒】结论可以归成四个数字：13 到 14 岁的 AI 用户 54% 每天都用；75% 会核查 AI 的答案；平均找一个节目要 14 分钟；18 到 34 岁有 54% 说找不到可能会退订。报告由此推出：离不开 AI 又不信 AI，节目难找导致退订，所以 AI 要接入可信数据。</a:t>
             </a:r>
             <a:endParaRPr lang="en-US" dirty="0"/>
           </a:p>
@@ -1617,7 +1617,7 @@
           <a:p>
             <a:r>
               <a:rPr lang="en-US" dirty="0"/>
-              <a:t>【约 30 秒】第一，对象。这 4003 人是 AI 聊天机器人用户，是一层层筛出来的人群，正文却常写成“美国人”。所谓 Alpha 世代，定义是 2010 到 2024 年出生，样本里只有 13 到 14 岁。这和课上 Durex 网络调查是同一个问题：网络样本能不能代表总体，现有说明判断不了。</a:t>
+              <a:t>【约 35 秒】第一，对象。这 4003 人都是用 AI 聊天机器人的人，是层层筛出来的，报告却常把结论说成“美国人”如何。它还把 13 到 14 岁叫作“Alpha 世代”，其实这个世代指 2010 到 2024 年出生的所有人。这和课上 Durex 网络调查一样：网络样本能否代表总体，现有说明判断不了。</a:t>
             </a:r>
             <a:endParaRPr lang="en-US" dirty="0"/>
           </a:p>
@@ -1705,7 +1705,7 @@
           <a:p>
             <a:r>
               <a:rPr lang="en-US" dirty="0"/>
-              <a:t>【约 30 秒】第二，总体。我对照了 Gracenote 上一份报告的原文：“找节目要 14 分钟”是六个国家的简单平均，美国自己是 12 分钟，是法国的 26 分钟把平均拉高了。可报告把它和美国尼尔森的收视数据画在了同一张图里。“54% 可能退订”也是六国口径。</a:t>
+              <a:t>【约 30 秒】第二，总体。“找节目要 14 分钟”来自 Gracenote 去年的六国调查。我找到那份调查的原始报告，它是分国家列的：美国 12 分钟，法国 26 分钟，14 分钟是六国平均。可这份报告把它放进了一张讲美国人看电视的图里。“54% 可能退订”也是六国的数字。</a:t>
             </a:r>
             <a:endParaRPr lang="en-US" dirty="0"/>
           </a:p>
@@ -1793,7 +1793,7 @@
           <a:p>
             <a:r>
               <a:rPr lang="en-US" dirty="0"/>
-              <a:t>【约 30 秒】第三，时间和分母。报告说 Pew 去年秋天测到 30% 的青少年每天用，几个月后它测到 54%，所以使用在“加速”。但 Pew 原文里，同样是 13 到 14 岁只有 24%，因为 Pew 问的是全体青少年，Gracenote 只问 AI 用户。换成同一分母，只差 10 个百分点左右。</a:t>
+              <a:t>【约 35 秒】第三，时间和分母。报告引用美国皮尤研究中心的数据：去年秋天 30% 的青少年每天用 AI，几个月后它测到 54%，于是说使用在“加速”。但皮尤原始数据里，同样 13 到 14 岁只有 24%：皮尤问的是所有青少年，Gracenote 只问用 AI 的人。都只看用 AI 的人，差距只剩 10 个百分点左右。</a:t>
             </a:r>
             <a:endParaRPr lang="en-US" dirty="0"/>
           </a:p>
@@ -1881,7 +1881,7 @@
           <a:p>
             <a:r>
               <a:rPr lang="en-US" dirty="0"/>
-              <a:t>【约 30 秒】第四，方法。那条因果链用了四种数据：问卷里的退订意向、行业的流失率、PwC 的全球预测、Veed 的机器测试。它们性质不同，也没有追踪同一批人，证明不了“找不到就退订”。还有些引用被放大了，比如 USC 的 38%，只是一个知识库、一个自动指标的结果。</a:t>
+              <a:t>【约 25 秒】第四，方法。为了说明“找不到就会退订”，报告拼了四种数据：问卷里的退订意愿、行业的退订率、普华永道的全球预测，还有一家公司让 AI 回答“剧在哪能看”的测试。它们性质各不相同，也没有追踪同一批人，证明不了这个因果关系。</a:t>
             </a:r>
             <a:endParaRPr lang="en-US" dirty="0"/>
           </a:p>
@@ -2027,7 +2027,7 @@
         <p:spPr>
           <a:xfrm>
             <a:off x="731520" y="3886200"/>
-            <a:ext cx="6583680" cy="1005840"/>
+            <a:ext cx="6583680" cy="1371600"/>
           </a:xfrm>
           <a:prstGeom prst="rect">
             <a:avLst/>
@@ -2128,42 +2128,6 @@
       </p:sp>
       <p:sp>
         <p:nvSpPr>
-          <p:cNvPr id="3" name="Text 0"/>
-          <p:cNvSpPr/>
-          <p:nvPr/>
-        </p:nvSpPr>
-        <p:spPr>
-          <a:xfrm>
-            <a:off x="731520" y="6355080"/>
-            <a:ext cx="8229600" cy="274320"/>
-          </a:xfrm>
-          <a:prstGeom prst="rect">
-            <a:avLst/>
-          </a:prstGeom>
-          <a:noFill/>
-          <a:ln/>
-        </p:spPr>
-        <p:txBody>
-          <a:bodyPr wrap="square" lIns="0" tIns="0" rIns="0" bIns="0" rtlCol="0" anchor="ctr"/>
-          <a:lstStyle/>
-          <a:p>
-            <a:pPr indent="0" marL="0">
-              <a:buNone/>
-            </a:pPr>
-            <a:r>
-              <a:rPr lang="en-US" sz="1000" dirty="0">
-                <a:solidFill>
-                  <a:schemeClr val="accent6"/>
-                </a:solidFill>
-              </a:rPr>
-              <a:t>Gracenote《TV Search and Discovery in the AI Era》解读 ｜ 市场调研：方法与实践</a:t>
-            </a:r>
-            <a:endParaRPr lang="en-US" sz="1000" dirty="0"/>
-          </a:p>
-        </p:txBody>
-      </p:sp>
-      <p:sp>
-        <p:nvSpPr>
           <p:cNvPr id="25" name="Slide Number Placeholder 0"/>
           <p:cNvSpPr>
             <a:spLocks noGrp="1"/>
@@ -2275,42 +2239,6 @@
               <a:buNone/>
             </a:pPr>
             <a:endParaRPr lang="en-US" sz="3000" dirty="0"/>
-          </a:p>
-        </p:txBody>
-      </p:sp>
-      <p:sp>
-        <p:nvSpPr>
-          <p:cNvPr id="3" name="Text 0"/>
-          <p:cNvSpPr/>
-          <p:nvPr/>
-        </p:nvSpPr>
-        <p:spPr>
-          <a:xfrm>
-            <a:off x="548640" y="6355080"/>
-            <a:ext cx="8229600" cy="274320"/>
-          </a:xfrm>
-          <a:prstGeom prst="rect">
-            <a:avLst/>
-          </a:prstGeom>
-          <a:noFill/>
-          <a:ln/>
-        </p:spPr>
-        <p:txBody>
-          <a:bodyPr wrap="square" lIns="0" tIns="0" rIns="0" bIns="0" rtlCol="0" anchor="ctr"/>
-          <a:lstStyle/>
-          <a:p>
-            <a:pPr indent="0" marL="0">
-              <a:buNone/>
-            </a:pPr>
-            <a:r>
-              <a:rPr lang="en-US" sz="1000" dirty="0">
-                <a:solidFill>
-                  <a:schemeClr val="accent5"/>
-                </a:solidFill>
-              </a:rPr>
-              <a:t>Gracenote《TV Search and Discovery in the AI Era》解读 ｜ 市场调研：方法与实践</a:t>
-            </a:r>
-            <a:endParaRPr lang="en-US" sz="1000" dirty="0"/>
           </a:p>
         </p:txBody>
       </p:sp>
@@ -2808,7 +2736,7 @@
         <p:spPr>
           <a:xfrm>
             <a:off x="731520" y="3886200"/>
-            <a:ext cx="6583680" cy="1005840"/>
+            <a:ext cx="6583680" cy="1371600"/>
           </a:xfrm>
           <a:prstGeom prst="rect">
             <a:avLst/>
@@ -2829,7 +2757,7 @@
                   <a:schemeClr val="accent6"/>
                 </a:solidFill>
               </a:rPr>
-              <a:t>解读 Gracenote（尼尔森旗下）2026 年报告</a:t>
+              <a:t>解读尼尔森旗下 Gracenote 2026 年的行业报告</a:t>
             </a:r>
             <a:endParaRPr lang="en-US" sz="1800" dirty="0"/>
           </a:p>
@@ -2844,6 +2772,20 @@
                 </a:solidFill>
               </a:rPr>
               <a:t>《TV Search and Discovery in the AI Era》</a:t>
+            </a:r>
+            <a:endParaRPr lang="en-US" sz="1800" dirty="0"/>
+          </a:p>
+          <a:p>
+            <a:pPr algn="l" indent="0" marL="0">
+              <a:buNone/>
+            </a:pPr>
+            <a:r>
+              <a:rPr lang="en-US" sz="1800" dirty="0">
+                <a:solidFill>
+                  <a:schemeClr val="accent6"/>
+                </a:solidFill>
+              </a:rPr>
+              <a:t>主题：AI 时代，人们怎样找电视节目</a:t>
             </a:r>
             <a:endParaRPr lang="en-US" sz="1800" dirty="0"/>
           </a:p>
@@ -3386,7 +3328,7 @@
                   <a:schemeClr val="bg1"/>
                 </a:solidFill>
               </a:rPr>
-              <a:t>图中数字可复算：CTV 占 54%、授权剧多 81%，都对得上</a:t>
+              <a:t>我用图里的原始数字复算了几处，都对得上</a:t>
             </a:r>
             <a:endParaRPr lang="en-US" sz="1400" dirty="0"/>
           </a:p>
@@ -3469,7 +3411,7 @@
                   <a:schemeClr val="bg1"/>
                 </a:solidFill>
               </a:rPr>
-              <a:t>行业方向的信号：年轻人在用 AI 找内容，但并不信任它。</a:t>
+              <a:t>行业趋势的信号：年轻人在用 AI 找节目，但并不信任它。</a:t>
             </a:r>
             <a:endParaRPr lang="en-US" sz="1800" dirty="0"/>
           </a:p>
@@ -3552,7 +3494,7 @@
                   <a:schemeClr val="bg1"/>
                 </a:solidFill>
               </a:rPr>
-              <a:t>对“美国人”的精确估计，或“找不到 → 退订”的因果证据。</a:t>
+              <a:t>对“美国人”的精确数据，或“找不到 → 退订”的因果证据。</a:t>
             </a:r>
             <a:endParaRPr lang="en-US" sz="1800" dirty="0"/>
           </a:p>
@@ -3688,7 +3630,7 @@
                   <a:schemeClr val="accent6"/>
                 </a:solidFill>
               </a:rPr>
-              <a:t>提醒：报告主张“需要可信的行业数据”正是 Gracenote 的业务。这是细看方法的理由，但不能据此断定数据有误。</a:t>
+              <a:t>提醒：报告的主张（AI 要接入可信的行业数据）正是 Gracenote 的业务。这是要细看方法的理由，但不能据此断定数据有误。</a:t>
             </a:r>
             <a:endParaRPr lang="en-US" sz="1200" dirty="0"/>
           </a:p>
@@ -6882,18 +6824,65 @@
       </p:sp>
       <p:sp>
         <p:nvSpPr>
-          <p:cNvPr id="3" name="问题卡1"/>
+          <p:cNvPr id="3" name="背景"/>
+          <p:cNvSpPr txBox="1"/>
+          <p:nvPr/>
+        </p:nvSpPr>
+        <p:spPr>
+          <a:xfrm>
+            <a:off x="548640" y="1234440"/>
+            <a:ext cx="11064240" cy="457200"/>
+          </a:xfrm>
+          <a:prstGeom prst="rect">
+            <a:avLst/>
+          </a:prstGeom>
+          <a:noFill/>
+          <a:ln/>
+        </p:spPr>
+        <p:txBody>
+          <a:bodyPr wrap="square" lIns="0" tIns="0" rIns="0" bIns="0" rtlCol="0" anchor="ctr"/>
+          <a:lstStyle/>
+          <a:p>
+            <a:pPr indent="0" marL="0">
+              <a:buNone/>
+            </a:pPr>
+            <a:r>
+              <a:rPr lang="en-US" sz="1600" b="1" dirty="0">
+                <a:solidFill>
+                  <a:schemeClr val="accent1"/>
+                </a:solidFill>
+              </a:rPr>
+              <a:t>背景：</a:t>
+            </a:r>
+            <a:pPr indent="0" marL="0">
+              <a:buNone/>
+            </a:pPr>
+            <a:r>
+              <a:rPr lang="en-US" sz="1600" dirty="0">
+                <a:solidFill>
+                  <a:schemeClr val="tx1"/>
+                </a:solidFill>
+              </a:rPr>
+              <a:t>流媒体平台越来越多，想看一部剧常常不知道去哪找；不少人开始直接问 ChatGPT 这类 AI 聊天机器人。</a:t>
+            </a:r>
+            <a:endParaRPr lang="en-US" sz="1600" dirty="0"/>
+          </a:p>
+        </p:txBody>
+      </p:sp>
+      <p:sp>
+        <p:nvSpPr>
+          <p:cNvPr id="4" name="问题卡1"/>
           <p:cNvSpPr/>
           <p:nvPr/>
         </p:nvSpPr>
         <p:spPr>
           <a:xfrm>
-            <a:off x="548640" y="1371600"/>
-            <a:ext cx="3474720" cy="2011680"/>
+            <a:off x="548640" y="1874520"/>
+            <a:ext cx="3474720" cy="1783080"/>
           </a:xfrm>
           <a:prstGeom prst="roundRect">
             <a:avLst>
-              <a:gd name="adj" fmla="val 5455"/>
+              <a:gd name="adj" fmla="val 6154"/>
             </a:avLst>
           </a:prstGeom>
           <a:solidFill>
@@ -6909,14 +6898,14 @@
       </p:sp>
       <p:sp>
         <p:nvSpPr>
-          <p:cNvPr id="4" name="图标底"/>
+          <p:cNvPr id="5" name="图标底"/>
           <p:cNvSpPr/>
           <p:nvPr/>
         </p:nvSpPr>
         <p:spPr>
           <a:xfrm>
-            <a:off x="822960" y="1645920"/>
-            <a:ext cx="640080" cy="640080"/>
+            <a:off x="822960" y="2057400"/>
+            <a:ext cx="594360" cy="594360"/>
           </a:xfrm>
           <a:prstGeom prst="ellipse">
             <a:avLst/>
@@ -6934,7 +6923,7 @@
       </p:sp>
       <p:pic>
         <p:nvPicPr>
-          <p:cNvPr id="5" name="图标" descr="preencoded.png">    </p:cNvPr>
+          <p:cNvPr id="6" name="图标" descr="preencoded.png">    </p:cNvPr>
           <p:cNvPicPr>
             <a:picLocks noChangeAspect="1"/>
           </p:cNvPicPr>
@@ -6948,8 +6937,8 @@
         </p:blipFill>
         <p:spPr>
           <a:xfrm>
-            <a:off x="982980" y="1805940"/>
-            <a:ext cx="320040" cy="320040"/>
+            <a:off x="971550" y="2205990"/>
+            <a:ext cx="297180" cy="297180"/>
           </a:xfrm>
           <a:prstGeom prst="rect">
             <a:avLst/>
@@ -6958,14 +6947,14 @@
       </p:pic>
       <p:sp>
         <p:nvSpPr>
-          <p:cNvPr id="6" name="问题标题1"/>
-          <p:cNvSpPr txBox="1"/>
-          <p:nvPr/>
-        </p:nvSpPr>
-        <p:spPr>
-          <a:xfrm>
-            <a:off x="1600200" y="1645920"/>
-            <a:ext cx="2286000" cy="640080"/>
+          <p:cNvPr id="7" name="问题标题1"/>
+          <p:cNvSpPr txBox="1"/>
+          <p:nvPr/>
+        </p:nvSpPr>
+        <p:spPr>
+          <a:xfrm>
+            <a:off x="1554480" y="2057400"/>
+            <a:ext cx="2286000" cy="594360"/>
           </a:xfrm>
           <a:prstGeom prst="rect">
             <a:avLst/>
@@ -6994,14 +6983,14 @@
       </p:sp>
       <p:sp>
         <p:nvSpPr>
-          <p:cNvPr id="7" name="问题内容1"/>
-          <p:cNvSpPr txBox="1"/>
-          <p:nvPr/>
-        </p:nvSpPr>
-        <p:spPr>
-          <a:xfrm>
-            <a:off x="822960" y="2423160"/>
-            <a:ext cx="2926080" cy="868680"/>
+          <p:cNvPr id="8" name="问题内容1"/>
+          <p:cNvSpPr txBox="1"/>
+          <p:nvPr/>
+        </p:nvSpPr>
+        <p:spPr>
+          <a:xfrm>
+            <a:off x="822960" y="2743200"/>
+            <a:ext cx="2926080" cy="777240"/>
           </a:xfrm>
           <a:prstGeom prst="rect">
             <a:avLst/>
@@ -7030,18 +7019,18 @@
       </p:sp>
       <p:sp>
         <p:nvSpPr>
-          <p:cNvPr id="8" name="问题卡2"/>
+          <p:cNvPr id="9" name="问题卡2"/>
           <p:cNvSpPr/>
           <p:nvPr/>
         </p:nvSpPr>
         <p:spPr>
           <a:xfrm>
-            <a:off x="4297680" y="1371600"/>
-            <a:ext cx="3474720" cy="2011680"/>
+            <a:off x="4297680" y="1874520"/>
+            <a:ext cx="3474720" cy="1783080"/>
           </a:xfrm>
           <a:prstGeom prst="roundRect">
             <a:avLst>
-              <a:gd name="adj" fmla="val 5455"/>
+              <a:gd name="adj" fmla="val 6154"/>
             </a:avLst>
           </a:prstGeom>
           <a:solidFill>
@@ -7057,14 +7046,14 @@
       </p:sp>
       <p:sp>
         <p:nvSpPr>
-          <p:cNvPr id="9" name="图标底"/>
+          <p:cNvPr id="10" name="图标底"/>
           <p:cNvSpPr/>
           <p:nvPr/>
         </p:nvSpPr>
         <p:spPr>
           <a:xfrm>
-            <a:off x="4572000" y="1645920"/>
-            <a:ext cx="640080" cy="640080"/>
+            <a:off x="4572000" y="2057400"/>
+            <a:ext cx="594360" cy="594360"/>
           </a:xfrm>
           <a:prstGeom prst="ellipse">
             <a:avLst/>
@@ -7082,7 +7071,7 @@
       </p:sp>
       <p:pic>
         <p:nvPicPr>
-          <p:cNvPr id="10" name="图标" descr="preencoded.png">    </p:cNvPr>
+          <p:cNvPr id="11" name="图标" descr="preencoded.png">    </p:cNvPr>
           <p:cNvPicPr>
             <a:picLocks noChangeAspect="1"/>
           </p:cNvPicPr>
@@ -7096,8 +7085,8 @@
         </p:blipFill>
         <p:spPr>
           <a:xfrm>
-            <a:off x="4732020" y="1805940"/>
-            <a:ext cx="320040" cy="320040"/>
+            <a:off x="4720590" y="2205990"/>
+            <a:ext cx="297180" cy="297180"/>
           </a:xfrm>
           <a:prstGeom prst="rect">
             <a:avLst/>
@@ -7106,14 +7095,14 @@
       </p:pic>
       <p:sp>
         <p:nvSpPr>
-          <p:cNvPr id="11" name="问题标题2"/>
-          <p:cNvSpPr txBox="1"/>
-          <p:nvPr/>
-        </p:nvSpPr>
-        <p:spPr>
-          <a:xfrm>
-            <a:off x="5349240" y="1645920"/>
-            <a:ext cx="2286000" cy="640080"/>
+          <p:cNvPr id="12" name="问题标题2"/>
+          <p:cNvSpPr txBox="1"/>
+          <p:nvPr/>
+        </p:nvSpPr>
+        <p:spPr>
+          <a:xfrm>
+            <a:off x="5303520" y="2057400"/>
+            <a:ext cx="2286000" cy="594360"/>
           </a:xfrm>
           <a:prstGeom prst="rect">
             <a:avLst/>
@@ -7142,14 +7131,14 @@
       </p:sp>
       <p:sp>
         <p:nvSpPr>
-          <p:cNvPr id="12" name="问题内容2"/>
-          <p:cNvSpPr txBox="1"/>
-          <p:nvPr/>
-        </p:nvSpPr>
-        <p:spPr>
-          <a:xfrm>
-            <a:off x="4572000" y="2423160"/>
-            <a:ext cx="2926080" cy="868680"/>
+          <p:cNvPr id="13" name="问题内容2"/>
+          <p:cNvSpPr txBox="1"/>
+          <p:nvPr/>
+        </p:nvSpPr>
+        <p:spPr>
+          <a:xfrm>
+            <a:off x="4572000" y="2743200"/>
+            <a:ext cx="2926080" cy="777240"/>
           </a:xfrm>
           <a:prstGeom prst="rect">
             <a:avLst/>
@@ -7178,18 +7167,18 @@
       </p:sp>
       <p:sp>
         <p:nvSpPr>
-          <p:cNvPr id="13" name="问题卡3"/>
+          <p:cNvPr id="14" name="问题卡3"/>
           <p:cNvSpPr/>
           <p:nvPr/>
         </p:nvSpPr>
         <p:spPr>
           <a:xfrm>
-            <a:off x="8046720" y="1371600"/>
-            <a:ext cx="3474720" cy="2011680"/>
+            <a:off x="8046720" y="1874520"/>
+            <a:ext cx="3474720" cy="1783080"/>
           </a:xfrm>
           <a:prstGeom prst="roundRect">
             <a:avLst>
-              <a:gd name="adj" fmla="val 5455"/>
+              <a:gd name="adj" fmla="val 6154"/>
             </a:avLst>
           </a:prstGeom>
           <a:solidFill>
@@ -7205,14 +7194,14 @@
       </p:sp>
       <p:sp>
         <p:nvSpPr>
-          <p:cNvPr id="14" name="图标底"/>
+          <p:cNvPr id="15" name="图标底"/>
           <p:cNvSpPr/>
           <p:nvPr/>
         </p:nvSpPr>
         <p:spPr>
           <a:xfrm>
-            <a:off x="8321040" y="1645920"/>
-            <a:ext cx="640080" cy="640080"/>
+            <a:off x="8321040" y="2057400"/>
+            <a:ext cx="594360" cy="594360"/>
           </a:xfrm>
           <a:prstGeom prst="ellipse">
             <a:avLst/>
@@ -7230,7 +7219,7 @@
       </p:sp>
       <p:pic>
         <p:nvPicPr>
-          <p:cNvPr id="15" name="图标" descr="preencoded.png">    </p:cNvPr>
+          <p:cNvPr id="16" name="图标" descr="preencoded.png">    </p:cNvPr>
           <p:cNvPicPr>
             <a:picLocks noChangeAspect="1"/>
           </p:cNvPicPr>
@@ -7244,8 +7233,8 @@
         </p:blipFill>
         <p:spPr>
           <a:xfrm>
-            <a:off x="8481060" y="1805940"/>
-            <a:ext cx="320040" cy="320040"/>
+            <a:off x="8469630" y="2205990"/>
+            <a:ext cx="297180" cy="297180"/>
           </a:xfrm>
           <a:prstGeom prst="rect">
             <a:avLst/>
@@ -7254,14 +7243,14 @@
       </p:pic>
       <p:sp>
         <p:nvSpPr>
-          <p:cNvPr id="16" name="问题标题3"/>
-          <p:cNvSpPr txBox="1"/>
-          <p:nvPr/>
-        </p:nvSpPr>
-        <p:spPr>
-          <a:xfrm>
-            <a:off x="9098280" y="1645920"/>
-            <a:ext cx="2286000" cy="640080"/>
+          <p:cNvPr id="17" name="问题标题3"/>
+          <p:cNvSpPr txBox="1"/>
+          <p:nvPr/>
+        </p:nvSpPr>
+        <p:spPr>
+          <a:xfrm>
+            <a:off x="9052560" y="2057400"/>
+            <a:ext cx="2286000" cy="594360"/>
           </a:xfrm>
           <a:prstGeom prst="rect">
             <a:avLst/>
@@ -7290,14 +7279,14 @@
       </p:sp>
       <p:sp>
         <p:nvSpPr>
-          <p:cNvPr id="17" name="问题内容3"/>
-          <p:cNvSpPr txBox="1"/>
-          <p:nvPr/>
-        </p:nvSpPr>
-        <p:spPr>
-          <a:xfrm>
-            <a:off x="8321040" y="2423160"/>
-            <a:ext cx="2926080" cy="868680"/>
+          <p:cNvPr id="18" name="问题内容3"/>
+          <p:cNvSpPr txBox="1"/>
+          <p:nvPr/>
+        </p:nvSpPr>
+        <p:spPr>
+          <a:xfrm>
+            <a:off x="8321040" y="2743200"/>
+            <a:ext cx="2926080" cy="777240"/>
           </a:xfrm>
           <a:prstGeom prst="rect">
             <a:avLst/>
@@ -7326,18 +7315,18 @@
       </p:sp>
       <p:sp>
         <p:nvSpPr>
-          <p:cNvPr id="18" name="机构与主张"/>
+          <p:cNvPr id="19" name="机构与主张"/>
           <p:cNvSpPr/>
           <p:nvPr/>
         </p:nvSpPr>
         <p:spPr>
           <a:xfrm>
-            <a:off x="548640" y="3657600"/>
-            <a:ext cx="11064240" cy="2103120"/>
+            <a:off x="548640" y="3886200"/>
+            <a:ext cx="11064240" cy="1920240"/>
           </a:xfrm>
           <a:prstGeom prst="roundRect">
             <a:avLst>
-              <a:gd name="adj" fmla="val 5217"/>
+              <a:gd name="adj" fmla="val 5714"/>
             </a:avLst>
           </a:prstGeom>
           <a:solidFill>
@@ -7353,13 +7342,13 @@
       </p:sp>
       <p:sp>
         <p:nvSpPr>
-          <p:cNvPr id="19" name="图标底"/>
+          <p:cNvPr id="20" name="图标底"/>
           <p:cNvSpPr/>
           <p:nvPr/>
         </p:nvSpPr>
         <p:spPr>
           <a:xfrm>
-            <a:off x="868680" y="4069080"/>
+            <a:off x="868680" y="4206240"/>
             <a:ext cx="548640" cy="548640"/>
           </a:xfrm>
           <a:prstGeom prst="ellipse">
@@ -7378,7 +7367,7 @@
       </p:sp>
       <p:pic>
         <p:nvPicPr>
-          <p:cNvPr id="20" name="图标" descr="preencoded.png">    </p:cNvPr>
+          <p:cNvPr id="21" name="图标" descr="preencoded.png">    </p:cNvPr>
           <p:cNvPicPr>
             <a:picLocks noChangeAspect="1"/>
           </p:cNvPicPr>
@@ -7392,7 +7381,7 @@
         </p:blipFill>
         <p:spPr>
           <a:xfrm>
-            <a:off x="1005840" y="4206240"/>
+            <a:off x="1005840" y="4343400"/>
             <a:ext cx="274320" cy="274320"/>
           </a:xfrm>
           <a:prstGeom prst="rect">
@@ -7402,14 +7391,14 @@
       </p:pic>
       <p:sp>
         <p:nvSpPr>
-          <p:cNvPr id="21" name="机构说明"/>
-          <p:cNvSpPr txBox="1"/>
-          <p:nvPr/>
-        </p:nvSpPr>
-        <p:spPr>
-          <a:xfrm>
-            <a:off x="1600200" y="3886200"/>
-            <a:ext cx="4206240" cy="1645920"/>
+          <p:cNvPr id="22" name="机构说明"/>
+          <p:cNvSpPr txBox="1"/>
+          <p:nvPr/>
+        </p:nvSpPr>
+        <p:spPr>
+          <a:xfrm>
+            <a:off x="1600200" y="4023360"/>
+            <a:ext cx="4297680" cy="1645920"/>
           </a:xfrm>
           <a:prstGeom prst="rect">
             <a:avLst/>
@@ -7450,7 +7439,7 @@
                   <a:schemeClr val="bg1"/>
                 </a:solidFill>
               </a:rPr>
-              <a:t>Gracenote，尼尔森旗下的内容数据业务，向媒体公司出售节目元数据：片名、简介、在哪个平台播出。</a:t>
+              <a:t>Gracenote，属于尼尔森（全球最大的收视率调查公司），专门给电视和流媒体平台提供节目资料：片名、简介、在哪能看。</a:t>
             </a:r>
             <a:endParaRPr lang="en-US" sz="1600" dirty="0"/>
           </a:p>
@@ -7458,13 +7447,13 @@
       </p:sp>
       <p:sp>
         <p:nvSpPr>
-          <p:cNvPr id="22" name="图标底"/>
+          <p:cNvPr id="23" name="图标底"/>
           <p:cNvSpPr/>
           <p:nvPr/>
         </p:nvSpPr>
         <p:spPr>
           <a:xfrm>
-            <a:off x="6263640" y="4069080"/>
+            <a:off x="6263640" y="4206240"/>
             <a:ext cx="548640" cy="548640"/>
           </a:xfrm>
           <a:prstGeom prst="ellipse">
@@ -7483,7 +7472,7 @@
       </p:sp>
       <p:pic>
         <p:nvPicPr>
-          <p:cNvPr id="23" name="图标" descr="preencoded.png">    </p:cNvPr>
+          <p:cNvPr id="24" name="图标" descr="preencoded.png">    </p:cNvPr>
           <p:cNvPicPr>
             <a:picLocks noChangeAspect="1"/>
           </p:cNvPicPr>
@@ -7497,7 +7486,7 @@
         </p:blipFill>
         <p:spPr>
           <a:xfrm>
-            <a:off x="6400800" y="4206240"/>
+            <a:off x="6400800" y="4343400"/>
             <a:ext cx="274320" cy="274320"/>
           </a:xfrm>
           <a:prstGeom prst="rect">
@@ -7507,13 +7496,13 @@
       </p:pic>
       <p:sp>
         <p:nvSpPr>
-          <p:cNvPr id="24" name="报告主张"/>
-          <p:cNvSpPr txBox="1"/>
-          <p:nvPr/>
-        </p:nvSpPr>
-        <p:spPr>
-          <a:xfrm>
-            <a:off x="6995160" y="3886200"/>
+          <p:cNvPr id="25" name="报告主张"/>
+          <p:cNvSpPr txBox="1"/>
+          <p:nvPr/>
+        </p:nvSpPr>
+        <p:spPr>
+          <a:xfrm>
+            <a:off x="6995160" y="4023360"/>
             <a:ext cx="4389120" cy="1645920"/>
           </a:xfrm>
           <a:prstGeom prst="rect">
@@ -7555,7 +7544,7 @@
                   <a:schemeClr val="bg1"/>
                 </a:solidFill>
               </a:rPr>
-              <a:t>AI 会成为找节目的入口，但必须接入可信的行业数据——这正是 Gracenote 卖的东西。</a:t>
+              <a:t>AI 会成为人们找节目的入口，但必须接入可信的行业数据——这正是 Gracenote 卖的东西。</a:t>
             </a:r>
             <a:endParaRPr lang="en-US" sz="1600" dirty="0"/>
           </a:p>
@@ -7726,7 +7715,7 @@
                   <a:schemeClr val="tx2"/>
                 </a:solidFill>
               </a:rPr>
-              <a:t>2026 生成式 AI 使用调查</a:t>
+              <a:t>调查一：2026 年 AI 使用调查</a:t>
             </a:r>
             <a:endParaRPr lang="en-US" sz="1800" dirty="0"/>
           </a:p>
@@ -7740,7 +7729,7 @@
                   <a:schemeClr val="accent5"/>
                 </a:solidFill>
               </a:rPr>
-              <a:t>支撑所有 AI 相关结论</a:t>
+              <a:t>报告里所有关于 AI 的数字都来自这里</a:t>
             </a:r>
             <a:endParaRPr lang="en-US" sz="1800" dirty="0"/>
           </a:p>
@@ -8190,7 +8179,7 @@
                   <a:schemeClr val="tx2"/>
                 </a:solidFill>
               </a:rPr>
-              <a:t>2025 流媒体消费者调查</a:t>
+              <a:t>调查二：2025 年六国流媒体调查</a:t>
             </a:r>
             <a:endParaRPr lang="en-US" sz="1800" dirty="0"/>
           </a:p>
@@ -8204,7 +8193,7 @@
                   <a:schemeClr val="accent5"/>
                 </a:solidFill>
               </a:rPr>
-              <a:t>支撑“找节目难”“会退订”等结论</a:t>
+              <a:t>“找节目难”“会退订”等数字来自这里</a:t>
             </a:r>
             <a:endParaRPr lang="en-US" sz="1800" dirty="0"/>
           </a:p>
@@ -8627,7 +8616,7 @@
                   <a:schemeClr val="tx1"/>
                 </a:solidFill>
               </a:rPr>
-              <a:t>另外还用了尼尔森收视测量、Gracenote 节目数据库，以及 Pew、Deloitte、PwC 等外部研究，共 11 个来源（核查见附录一）。</a:t>
+              <a:t>此外还引用了尼尔森收视率数据、Gracenote 节目资料库，以及皮尤、德勤、普华永道等机构的研究，共 11 个来源（核查见附录一）。</a:t>
             </a:r>
             <a:endParaRPr lang="en-US" sz="1400" dirty="0"/>
           </a:p>
@@ -8663,7 +8652,7 @@
                   <a:schemeClr val="accent5"/>
                 </a:solidFill>
               </a:rPr>
-              <a:t>来源：报告第 23 页；Nielsen 新闻稿（2026.4）；Gracenote 2025《State of Play》第 20 页。</a:t>
+              <a:t>来源：报告的数据说明；尼尔森新闻稿（2026.4）；Gracenote 2025 年报告《State of Play》的数据说明。</a:t>
             </a:r>
             <a:endParaRPr lang="en-US" sz="1000" dirty="0"/>
           </a:p>
@@ -8873,7 +8862,7 @@
                   <a:schemeClr val="tx1"/>
                 </a:solidFill>
               </a:rPr>
-              <a:t>13–14 岁 AI 用户每天使用 AI 聊天机器人</a:t>
+              <a:t>13–14 岁 AI 用户每天都用（报告称为“Alpha 世代”）</a:t>
             </a:r>
             <a:endParaRPr lang="en-US" sz="1500" dirty="0"/>
           </a:p>
@@ -8909,7 +8898,7 @@
                   <a:schemeClr val="accent5"/>
                 </a:solidFill>
               </a:rPr>
-              <a:t>2026 AI 调查</a:t>
+              <a:t>调查一</a:t>
             </a:r>
             <a:endParaRPr lang="en-US" sz="1100" dirty="0"/>
           </a:p>
@@ -9047,7 +9036,7 @@
                   <a:schemeClr val="accent5"/>
                 </a:solidFill>
               </a:rPr>
-              <a:t>2026 AI 调查</a:t>
+              <a:t>调查一</a:t>
             </a:r>
             <a:endParaRPr lang="en-US" sz="1100" dirty="0"/>
           </a:p>
@@ -9185,7 +9174,7 @@
                   <a:schemeClr val="accent5"/>
                 </a:solidFill>
               </a:rPr>
-              <a:t>2025 六国调查</a:t>
+              <a:t>调查二（六国）</a:t>
             </a:r>
             <a:endParaRPr lang="en-US" sz="1100" dirty="0"/>
           </a:p>
@@ -9323,7 +9312,7 @@
                   <a:schemeClr val="accent5"/>
                 </a:solidFill>
               </a:rPr>
-              <a:t>2025 六国调查</a:t>
+              <a:t>调查二（六国）</a:t>
             </a:r>
             <a:endParaRPr lang="en-US" sz="1100" dirty="0"/>
           </a:p>
@@ -9755,7 +9744,7 @@
                   <a:schemeClr val="accent5"/>
                 </a:solidFill>
               </a:rPr>
-              <a:t>来源：报告第 2、5、9、14、18 页。</a:t>
+              <a:t>来源：Gracenote 报告正文与图表。</a:t>
             </a:r>
             <a:endParaRPr lang="en-US" sz="1000" dirty="0"/>
           </a:p>
@@ -11248,7 +11237,7 @@
                   <a:schemeClr val="tx1"/>
                 </a:solidFill>
               </a:rPr>
-              <a:t>调查对象是“互联网和 AI 聊天机器人用户”，正文却常写成 “Americans”“U.S. consumers”。</a:t>
+              <a:t>调查的是“用 AI 聊天机器人的人”，正文却常把结论写成“美国人”如何如何。</a:t>
             </a:r>
             <a:endParaRPr lang="en-US" sz="1600" dirty="0"/>
           </a:p>
@@ -11304,7 +11293,7 @@
                   <a:schemeClr val="tx1"/>
                 </a:solidFill>
               </a:rPr>
-              <a:t>定义是 2010–2024 年出生，样本里只有 13–14 岁这两岁。</a:t>
+              <a:t>报告把 13–14 岁受访者叫作 Alpha 世代；这个世代其实指 2010–2024 年出生的所有人。</a:t>
             </a:r>
             <a:endParaRPr lang="en-US" sz="1600" dirty="0"/>
           </a:p>
@@ -11459,7 +11448,7 @@
                   <a:schemeClr val="accent5"/>
                 </a:solidFill>
               </a:rPr>
-              <a:t>来源：报告第 2、5、6、20、23 页；Nielsen 新闻稿（“Gen Alpha findings are based on respondents ages 13 and 14”）。</a:t>
+              <a:t>来源：Gracenote 报告；尼尔森新闻稿原文：“Gen Alpha findings are based on respondents ages 13 and 14”。</a:t>
             </a:r>
             <a:endParaRPr lang="en-US" sz="1000" dirty="0"/>
           </a:p>
@@ -11934,7 +11923,7 @@
                   <a:schemeClr val="tx1"/>
                 </a:solidFill>
               </a:rPr>
-              <a:t>六国简单平均：美国自己 12 分钟，法国 26 分钟拉高了平均。报告却把它和美国尼尔森收视数据画在同一张图里。</a:t>
+              <a:t>来自 Gracenote 去年的六国调查：美国 12 分钟，14 分钟是六国平均。这份报告却把它放进讲美国人看电视的图里。</a:t>
             </a:r>
             <a:endParaRPr lang="en-US" sz="1400" dirty="0"/>
           </a:p>
@@ -12033,7 +12022,7 @@
                   <a:schemeClr val="tx1"/>
                 </a:solidFill>
               </a:rPr>
-              <a:t>“18–34 岁可能退订”与六国数据吻合；“50% 的美国观众会考虑取消”，原文只找到六国 49%。</a:t>
+              <a:t>“18–34 岁可能退订”也是六国数字；报告另说“50% 的美国观众会考虑退订”，原始报告里只有六国的 49%。</a:t>
             </a:r>
             <a:endParaRPr lang="en-US" sz="1400" dirty="0"/>
           </a:p>
@@ -12132,7 +12121,7 @@
                   <a:schemeClr val="tx1"/>
                 </a:solidFill>
               </a:rPr>
-              <a:t>与六国平均一致；第 12 页同一题写成“34% 的美国人”。</a:t>
+              <a:t>同一道题，报告一处写 32%（六国平均），另一处写成“34% 的美国人”。</a:t>
             </a:r>
             <a:endParaRPr lang="en-US" sz="1400" dirty="0"/>
           </a:p>
@@ -12168,7 +12157,7 @@
                   <a:schemeClr val="accent5"/>
                 </a:solidFill>
               </a:rPr>
-              <a:t>来源：报告第 2、6、9、12 页；Gracenote 2025《State of Play》分国家、分年龄图表（每国 500 人）。</a:t>
+              <a:t>来源：Gracenote 报告；Gracenote 2025 年报告《State of Play》分国家、分年龄图表（每国 500 人）。</a:t>
             </a:r>
             <a:endParaRPr lang="en-US" sz="1000" dirty="0"/>
           </a:p>
@@ -12564,7 +12553,7 @@
                   <a:schemeClr val="tx2"/>
                 </a:solidFill>
               </a:rPr>
-              <a:t>报告原话：Pew 2025 年秋发现 30% 的青少年每天用聊天机器人，“仅仅几个月后”Gracenote 调查显示超过一半，说明使用频率“在加速”。</a:t>
+              <a:t>报告原话：皮尤研究中心 2025 年秋发现 30% 的青少年每天用 AI 聊天机器人，“仅仅几个月后”我们的调查显示超过一半，说明使用频率“在加速”。</a:t>
             </a:r>
             <a:endParaRPr lang="en-US" sz="1500" dirty="0"/>
           </a:p>
@@ -12627,7 +12616,7 @@
                   <a:schemeClr val="accent5"/>
                 </a:solidFill>
               </a:rPr>
-              <a:t>Pew 研究中心</a:t>
+              <a:t>皮尤研究中心（Pew，美国权威民调机构）</a:t>
             </a:r>
             <a:endParaRPr lang="en-US" sz="1600" dirty="0"/>
           </a:p>
@@ -12796,7 +12785,7 @@
                   <a:schemeClr val="accent1"/>
                 </a:solidFill>
               </a:rPr>
-              <a:t>Gracenote</a:t>
+              <a:t>Gracenote（本报告）</a:t>
             </a:r>
             <a:endParaRPr lang="en-US" sz="1600" dirty="0"/>
           </a:p>
@@ -13001,7 +12990,7 @@
                   <a:schemeClr val="accent6"/>
                 </a:solidFill>
               </a:rPr>
-              <a:t>换成同一分母（只看使用者）：</a:t>
+              <a:t>如果都只看用 AI 的人：</a:t>
             </a:r>
             <a:pPr indent="0" marL="0">
               <a:buNone/>
@@ -13012,7 +13001,7 @@
                   <a:schemeClr val="bg1"/>
                 </a:solidFill>
               </a:rPr>
-              <a:t>Pew 44% 对 Gracenote 54%，只差约 10 个百分点。剩下的差距还可能来自年龄、方法、时间不同，不能说明“加速”。</a:t>
+              <a:t>皮尤 44% 对 Gracenote 54%，只差约 10 个百分点。剩下的差距还可能来自年龄、方法、时间不同，不能说明“加速”。</a:t>
             </a:r>
             <a:endParaRPr lang="en-US" sz="1500" dirty="0"/>
           </a:p>
@@ -13048,7 +13037,7 @@
                   <a:schemeClr val="accent5"/>
                 </a:solidFill>
               </a:rPr>
-              <a:t>来源：报告第 14 页；Pew《Teens, Social Media and AI Chatbots 2025》数据表（全体每天 28%，13–14 岁 24%，使用者 44%）。</a:t>
+              <a:t>来源：Gracenote 报告；皮尤《Teens, Social Media and AI Chatbots 2025》数据表（全体每天 28%，13–14 岁 24%，使用者中 44%）。</a:t>
             </a:r>
             <a:endParaRPr lang="en-US" sz="1000" dirty="0"/>
           </a:p>
@@ -13156,7 +13145,7 @@
                   <a:schemeClr val="tx2"/>
                 </a:solidFill>
               </a:rPr>
-              <a:t>方法：四种数据串成一条因果链</a:t>
+              <a:t>方法：四种数据拼成一条因果链</a:t>
             </a:r>
             <a:endParaRPr lang="en-US" sz="3000" dirty="0"/>
           </a:p>
@@ -13546,7 +13535,7 @@
                   <a:schemeClr val="tx1"/>
                 </a:solidFill>
               </a:rPr>
-              <a:t>18–34 岁“可能会退订”</a:t>
+              <a:t>18–34 岁说“可能会退订”</a:t>
             </a:r>
             <a:endParaRPr lang="en-US" sz="1400" dirty="0"/>
           </a:p>
@@ -13563,7 +13552,7 @@
                   <a:schemeClr val="accent3"/>
                 </a:solidFill>
               </a:rPr>
-              <a:t>六国口径</a:t>
+              <a:t>六国数字</a:t>
             </a:r>
             <a:endParaRPr lang="en-US" sz="1400" dirty="0"/>
           </a:p>
@@ -13662,7 +13651,7 @@
                   <a:schemeClr val="accent2"/>
                 </a:solidFill>
               </a:rPr>
-              <a:t>行为 · 行业指标</a:t>
+              <a:t>行为 · 行业统计</a:t>
             </a:r>
             <a:endParaRPr lang="en-US" sz="1400" dirty="0"/>
           </a:p>
@@ -13737,7 +13726,7 @@
                   <a:schemeClr val="tx1"/>
                 </a:solidFill>
               </a:rPr>
-              <a:t>主要平台月流失率</a:t>
+              <a:t>流媒体平台每月退订率</a:t>
             </a:r>
             <a:endParaRPr lang="en-US" sz="1400" dirty="0"/>
           </a:p>
@@ -13754,7 +13743,7 @@
                   <a:schemeClr val="accent3"/>
                 </a:solidFill>
               </a:rPr>
-              <a:t>定义未公开；另一机构测得 2019 年已是 4.1%</a:t>
+              <a:t>算法未公开；另一机构测得 2019 年已是 4.1%</a:t>
             </a:r>
             <a:endParaRPr lang="en-US" sz="1400" dirty="0"/>
           </a:p>
@@ -13853,7 +13842,7 @@
                   <a:schemeClr val="tx2"/>
                 </a:solidFill>
               </a:rPr>
-              <a:t>预测 · 模型</a:t>
+              <a:t>预测 · 普华永道</a:t>
             </a:r>
             <a:endParaRPr lang="en-US" sz="1400" dirty="0"/>
           </a:p>
@@ -13928,7 +13917,7 @@
                   <a:schemeClr val="tx1"/>
                 </a:solidFill>
               </a:rPr>
-              <a:t>OTT + 付费电视 2029 年支出</a:t>
+              <a:t>网络视频与付费电视 2029 年总支出</a:t>
             </a:r>
             <a:endParaRPr lang="en-US" sz="1400" dirty="0"/>
           </a:p>
@@ -13945,7 +13934,7 @@
                   <a:schemeClr val="accent3"/>
                 </a:solidFill>
               </a:rPr>
-              <a:t>PwC 的全球数字，不是美国</a:t>
+              <a:t>全球数字，不是美国</a:t>
             </a:r>
             <a:endParaRPr lang="en-US" sz="1400" dirty="0"/>
           </a:p>
@@ -14044,7 +14033,7 @@
                   <a:schemeClr val="accent5"/>
                 </a:solidFill>
               </a:rPr>
-              <a:t>测试 · 机器</a:t>
+              <a:t>测试 · 让 AI 答题</a:t>
             </a:r>
             <a:endParaRPr lang="en-US" sz="1400" dirty="0"/>
           </a:p>
@@ -14119,7 +14108,7 @@
                   <a:schemeClr val="tx1"/>
                 </a:solidFill>
               </a:rPr>
-              <a:t>聊天机器人找对播出平台</a:t>
+              <a:t>AI 答对了剧在哪个平台能看</a:t>
             </a:r>
             <a:endParaRPr lang="en-US" sz="1400" dirty="0"/>
           </a:p>
@@ -14219,7 +14208,7 @@
                   <a:schemeClr val="tx1"/>
                 </a:solidFill>
               </a:rPr>
-              <a:t>没有追踪同一批人，也没有做实验，证明不了“找不到 → 退订”；“接入 MCP 信息就不会过时”也没有检验。</a:t>
+              <a:t>四种数据对象不同、性质不同，也没追踪同一批人或做实验，证明不了“找不到 → 退订”；报告提出的办法（让 AI 接入行业数据库）也没有检验效果。</a:t>
             </a:r>
             <a:endParaRPr lang="en-US" sz="1600" dirty="0"/>
           </a:p>
@@ -14302,7 +14291,7 @@
                   <a:schemeClr val="tx1"/>
                 </a:solidFill>
               </a:rPr>
-              <a:t>USC 的 38%：只是一个知识库、一个自动指标（与人工判断一致率 60.9%）。Deloitte 的 41%：分母是全体消费者，报告写成“订户”。</a:t>
+              <a:t>南加州大学研究的“38% 数据有偏差”，只是一个知识库、一个自动打分指标的结果；德勤的“41% 觉得不值”指全体消费者，报告写成了“订户”。</a:t>
             </a:r>
             <a:endParaRPr lang="en-US" sz="1600" dirty="0"/>
           </a:p>
@@ -14338,7 +14327,7 @@
                   <a:schemeClr val="accent5"/>
                 </a:solidFill>
               </a:rPr>
-              <a:t>来源：报告第 5、6、9、22 页；PwC、Veed（作者原文与 NAB 2026）、USC 论文（EMNLP 2021）、Deloitte 方法说明；Antenna 数据经 MediaPost 转述。</a:t>
+              <a:t>来源：Gracenote 报告；普华永道（PwC）、Veed Analytics 测试、南加州大学论文（EMNLP 2021）、德勤（Deloitte）原文；Antenna 数据经 MediaPost 转述。</a:t>
             </a:r>
             <a:endParaRPr lang="en-US" sz="1000" dirty="0"/>
           </a:p>

</xml_diff>